<commit_message>
Update Project 3 pipeline and documentation
</commit_message>
<xml_diff>
--- a/Project 3/docs/Rapido_Student_Teaching_Deck.pptx
+++ b/Project 3/docs/Rapido_Student_Teaching_Deck.pptx
@@ -6,38 +6,28 @@
   </p:sldMasterIdLst>
   <p:sldIdLst>
     <p:sldId id="256" r:id="rId2"/>
-    <p:sldId id="257" r:id="rId3"/>
-    <p:sldId id="258" r:id="rId4"/>
-    <p:sldId id="259" r:id="rId5"/>
-    <p:sldId id="260" r:id="rId6"/>
-    <p:sldId id="261" r:id="rId7"/>
-    <p:sldId id="262" r:id="rId8"/>
-    <p:sldId id="263" r:id="rId9"/>
-    <p:sldId id="264" r:id="rId10"/>
-    <p:sldId id="265" r:id="rId11"/>
-    <p:sldId id="266" r:id="rId12"/>
-    <p:sldId id="267" r:id="rId13"/>
-    <p:sldId id="268" r:id="rId14"/>
-    <p:sldId id="269" r:id="rId15"/>
-    <p:sldId id="270" r:id="rId16"/>
-    <p:sldId id="271" r:id="rId17"/>
-    <p:sldId id="272" r:id="rId18"/>
-    <p:sldId id="273" r:id="rId19"/>
-    <p:sldId id="274" r:id="rId20"/>
-    <p:sldId id="275" r:id="rId21"/>
-    <p:sldId id="276" r:id="rId22"/>
-    <p:sldId id="277" r:id="rId23"/>
-    <p:sldId id="278" r:id="rId24"/>
-    <p:sldId id="279" r:id="rId25"/>
-    <p:sldId id="280" r:id="rId26"/>
-    <p:sldId id="281" r:id="rId27"/>
-    <p:sldId id="282" r:id="rId28"/>
-    <p:sldId id="283" r:id="rId29"/>
-    <p:sldId id="284" r:id="rId30"/>
-    <p:sldId id="285" r:id="rId31"/>
-    <p:sldId id="286" r:id="rId32"/>
-    <p:sldId id="287" r:id="rId33"/>
-    <p:sldId id="288" r:id="rId34"/>
+    <p:sldId id="259" r:id="rId3"/>
+    <p:sldId id="260" r:id="rId4"/>
+    <p:sldId id="261" r:id="rId5"/>
+    <p:sldId id="262" r:id="rId6"/>
+    <p:sldId id="263" r:id="rId7"/>
+    <p:sldId id="264" r:id="rId8"/>
+    <p:sldId id="266" r:id="rId9"/>
+    <p:sldId id="267" r:id="rId10"/>
+    <p:sldId id="268" r:id="rId11"/>
+    <p:sldId id="269" r:id="rId12"/>
+    <p:sldId id="270" r:id="rId13"/>
+    <p:sldId id="271" r:id="rId14"/>
+    <p:sldId id="272" r:id="rId15"/>
+    <p:sldId id="273" r:id="rId16"/>
+    <p:sldId id="274" r:id="rId17"/>
+    <p:sldId id="276" r:id="rId18"/>
+    <p:sldId id="277" r:id="rId19"/>
+    <p:sldId id="278" r:id="rId20"/>
+    <p:sldId id="279" r:id="rId21"/>
+    <p:sldId id="281" r:id="rId22"/>
+    <p:sldId id="282" r:id="rId23"/>
+    <p:sldId id="284" r:id="rId24"/>
   </p:sldIdLst>
   <p:sldSz cx="9144000" cy="6858000" type="screen4x3"/>
   <p:notesSz cx="6858000" cy="9144000"/>
@@ -334,7 +324,7 @@
           <a:p>
             <a:fld id="{5BCAD085-E8A6-8845-BD4E-CB4CCA059FC4}" type="datetimeFigureOut">
               <a:rPr lang="en-US" smtClean="0"/>
-              <a:t>8/7/2026</a:t>
+              <a:t>10/2/2026</a:t>
             </a:fld>
             <a:endParaRPr lang="en-US"/>
           </a:p>
@@ -502,7 +492,7 @@
           <a:p>
             <a:fld id="{5BCAD085-E8A6-8845-BD4E-CB4CCA059FC4}" type="datetimeFigureOut">
               <a:rPr lang="en-US" smtClean="0"/>
-              <a:t>8/7/2026</a:t>
+              <a:t>10/2/2026</a:t>
             </a:fld>
             <a:endParaRPr lang="en-US"/>
           </a:p>
@@ -680,7 +670,7 @@
           <a:p>
             <a:fld id="{5BCAD085-E8A6-8845-BD4E-CB4CCA059FC4}" type="datetimeFigureOut">
               <a:rPr lang="en-US" smtClean="0"/>
-              <a:t>8/7/2026</a:t>
+              <a:t>10/2/2026</a:t>
             </a:fld>
             <a:endParaRPr lang="en-US"/>
           </a:p>
@@ -848,7 +838,7 @@
           <a:p>
             <a:fld id="{5BCAD085-E8A6-8845-BD4E-CB4CCA059FC4}" type="datetimeFigureOut">
               <a:rPr lang="en-US" smtClean="0"/>
-              <a:t>8/7/2026</a:t>
+              <a:t>10/2/2026</a:t>
             </a:fld>
             <a:endParaRPr lang="en-US"/>
           </a:p>
@@ -1093,7 +1083,7 @@
           <a:p>
             <a:fld id="{5BCAD085-E8A6-8845-BD4E-CB4CCA059FC4}" type="datetimeFigureOut">
               <a:rPr lang="en-US" smtClean="0"/>
-              <a:t>8/7/2026</a:t>
+              <a:t>10/2/2026</a:t>
             </a:fld>
             <a:endParaRPr lang="en-US"/>
           </a:p>
@@ -1378,7 +1368,7 @@
           <a:p>
             <a:fld id="{5BCAD085-E8A6-8845-BD4E-CB4CCA059FC4}" type="datetimeFigureOut">
               <a:rPr lang="en-US" smtClean="0"/>
-              <a:t>8/7/2026</a:t>
+              <a:t>10/2/2026</a:t>
             </a:fld>
             <a:endParaRPr lang="en-US"/>
           </a:p>
@@ -1797,7 +1787,7 @@
           <a:p>
             <a:fld id="{5BCAD085-E8A6-8845-BD4E-CB4CCA059FC4}" type="datetimeFigureOut">
               <a:rPr lang="en-US" smtClean="0"/>
-              <a:t>8/7/2026</a:t>
+              <a:t>10/2/2026</a:t>
             </a:fld>
             <a:endParaRPr lang="en-US"/>
           </a:p>
@@ -1914,7 +1904,7 @@
           <a:p>
             <a:fld id="{5BCAD085-E8A6-8845-BD4E-CB4CCA059FC4}" type="datetimeFigureOut">
               <a:rPr lang="en-US" smtClean="0"/>
-              <a:t>8/7/2026</a:t>
+              <a:t>10/2/2026</a:t>
             </a:fld>
             <a:endParaRPr lang="en-US"/>
           </a:p>
@@ -2009,7 +1999,7 @@
           <a:p>
             <a:fld id="{5BCAD085-E8A6-8845-BD4E-CB4CCA059FC4}" type="datetimeFigureOut">
               <a:rPr lang="en-US" smtClean="0"/>
-              <a:t>8/7/2026</a:t>
+              <a:t>10/2/2026</a:t>
             </a:fld>
             <a:endParaRPr lang="en-US"/>
           </a:p>
@@ -2284,7 +2274,7 @@
           <a:p>
             <a:fld id="{5BCAD085-E8A6-8845-BD4E-CB4CCA059FC4}" type="datetimeFigureOut">
               <a:rPr lang="en-US" smtClean="0"/>
-              <a:t>8/7/2026</a:t>
+              <a:t>10/2/2026</a:t>
             </a:fld>
             <a:endParaRPr lang="en-US"/>
           </a:p>
@@ -2536,7 +2526,7 @@
           <a:p>
             <a:fld id="{5BCAD085-E8A6-8845-BD4E-CB4CCA059FC4}" type="datetimeFigureOut">
               <a:rPr lang="en-US" smtClean="0"/>
-              <a:t>8/7/2026</a:t>
+              <a:t>10/2/2026</a:t>
             </a:fld>
             <a:endParaRPr lang="en-US"/>
           </a:p>
@@ -2747,7 +2737,7 @@
           <a:p>
             <a:fld id="{5BCAD085-E8A6-8845-BD4E-CB4CCA059FC4}" type="datetimeFigureOut">
               <a:rPr lang="en-US" smtClean="0"/>
-              <a:t>8/7/2026</a:t>
+              <a:t>10/2/2026</a:t>
             </a:fld>
             <a:endParaRPr lang="en-US"/>
           </a:p>
@@ -3145,7 +3135,13 @@
       </p:sp>
       <p:sp>
         <p:nvSpPr>
-          <p:cNvPr id="3" name="Subtitle 2"/>
+          <p:cNvPr id="5" name="Subtitle 4">
+            <a:extLst>
+              <a:ext uri="{FF2B5EF4-FFF2-40B4-BE49-F238E27FC236}">
+                <a16:creationId xmlns:a16="http://schemas.microsoft.com/office/drawing/2014/main" id="{4AF0D782-A799-6F91-8350-CF9729301C32}"/>
+              </a:ext>
+            </a:extLst>
+          </p:cNvPr>
           <p:cNvSpPr>
             <a:spLocks noGrp="1"/>
           </p:cNvSpPr>
@@ -3158,10 +3154,7 @@
           <a:bodyPr/>
           <a:lstStyle/>
           <a:p>
-            <a:r>
-              <a:rPr dirty="0"/>
-              <a:t>Intelligent Mobility Insights: Ride Patterns, Cancellations, Fare Forecasting</a:t>
-            </a:r>
+            <a:endParaRPr lang="en-US"/>
           </a:p>
         </p:txBody>
       </p:sp>
@@ -3206,8 +3199,7 @@
           <a:lstStyle/>
           <a:p>
             <a:r>
-              <a:rPr dirty="0"/>
-              <a:t>Checklist Before Coding</a:t>
+              <a:t>Step 2: Install Required Packages</a:t>
             </a:r>
           </a:p>
         </p:txBody>
@@ -3231,51 +3223,23 @@
               <a:defRPr sz="2200"/>
             </a:pPr>
             <a:r>
-              <a:rPr dirty="0"/>
-              <a:t>Can they identify target columns for each use case?</a:t>
-            </a:r>
-          </a:p>
-          <a:p>
-            <a:pPr>
-              <a:defRPr sz="2200"/>
-            </a:pPr>
-            <a:r>
-              <a:rPr dirty="0"/>
-              <a:t>Can they explain one row from each CSV in plain language?</a:t>
-            </a:r>
-          </a:p>
-          <a:p>
-            <a:pPr>
-              <a:defRPr sz="2200"/>
-            </a:pPr>
-            <a:r>
-              <a:rPr dirty="0"/>
-              <a:t>Can they list which file connects by </a:t>
-            </a:r>
-            <a:r>
-              <a:rPr dirty="0" err="1"/>
-              <a:t>customer_id</a:t>
-            </a:r>
-            <a:r>
-              <a:rPr dirty="0"/>
-              <a:t> and </a:t>
-            </a:r>
-            <a:r>
-              <a:rPr dirty="0" err="1"/>
-              <a:t>driver_id</a:t>
-            </a:r>
-            <a:r>
-              <a:rPr dirty="0"/>
-              <a:t>?</a:t>
-            </a:r>
-          </a:p>
-          <a:p>
-            <a:pPr>
-              <a:defRPr sz="2200"/>
-            </a:pPr>
-            <a:r>
-              <a:rPr dirty="0"/>
-              <a:t>Do they understand that clean data comes before model training?</a:t>
+              <a:t>Run pip install -r requirements.txt</a:t>
+            </a:r>
+          </a:p>
+          <a:p>
+            <a:pPr>
+              <a:defRPr sz="2200"/>
+            </a:pPr>
+            <a:r>
+              <a:t>Explain that dependencies are libraries our code needs.</a:t>
+            </a:r>
+          </a:p>
+          <a:p>
+            <a:pPr>
+              <a:defRPr sz="2200"/>
+            </a:pPr>
+            <a:r>
+              <a:t>If any error appears, read first red line and fix one issue at a time.</a:t>
             </a:r>
           </a:p>
         </p:txBody>
@@ -3321,38 +3285,47 @@
           <a:lstStyle/>
           <a:p>
             <a:r>
-              <a:t>Part 3</a:t>
-            </a:r>
-          </a:p>
-        </p:txBody>
-      </p:sp>
-      <p:sp>
-        <p:nvSpPr>
-          <p:cNvPr id="3" name="TextBox 2"/>
-          <p:cNvSpPr txBox="1"/>
-          <p:nvPr/>
-        </p:nvSpPr>
-        <p:spPr>
-          <a:xfrm>
-            <a:off x="914400" y="2011680"/>
-            <a:ext cx="10058400" cy="2286000"/>
-          </a:xfrm>
-          <a:prstGeom prst="rect">
-            <a:avLst/>
-          </a:prstGeom>
-          <a:noFill/>
-        </p:spPr>
-        <p:txBody>
-          <a:bodyPr wrap="none">
-            <a:spAutoFit/>
-          </a:bodyPr>
-          <a:lstStyle/>
-          <a:p>
-            <a:pPr>
-              <a:defRPr sz="2800"/>
-            </a:pPr>
-            <a:r>
-              <a:t>Environment setup and project execution</a:t>
+              <a:t>Step 3: Run Full Pipeline</a:t>
+            </a:r>
+          </a:p>
+        </p:txBody>
+      </p:sp>
+      <p:sp>
+        <p:nvSpPr>
+          <p:cNvPr id="3" name="Content Placeholder 2"/>
+          <p:cNvSpPr>
+            <a:spLocks noGrp="1"/>
+          </p:cNvSpPr>
+          <p:nvPr>
+            <p:ph idx="1"/>
+          </p:nvPr>
+        </p:nvSpPr>
+        <p:spPr/>
+        <p:txBody>
+          <a:bodyPr/>
+          <a:lstStyle/>
+          <a:p>
+            <a:pPr>
+              <a:defRPr sz="2200"/>
+            </a:pPr>
+            <a:r>
+              <a:t>Run python -m src.run_pipeline</a:t>
+            </a:r>
+          </a:p>
+          <a:p>
+            <a:pPr>
+              <a:defRPr sz="2200"/>
+            </a:pPr>
+            <a:r>
+              <a:t>This runs EDA, cleaning and merging, feature engineering, training, and SQL export.</a:t>
+            </a:r>
+          </a:p>
+          <a:p>
+            <a:pPr>
+              <a:defRPr sz="2200"/>
+            </a:pPr>
+            <a:r>
+              <a:t>Expected output includes model files and metrics report.</a:t>
             </a:r>
           </a:p>
         </p:txBody>
@@ -3398,7 +3371,8 @@
           <a:lstStyle/>
           <a:p>
             <a:r>
-              <a:t>Step 1: Open The Project</a:t>
+              <a:rPr dirty="0"/>
+              <a:t>What Should Verify After Pipeline</a:t>
             </a:r>
           </a:p>
         </p:txBody>
@@ -3422,31 +3396,72 @@
               <a:defRPr sz="2200"/>
             </a:pPr>
             <a:r>
-              <a:t>Open VS Code.</a:t>
-            </a:r>
-          </a:p>
-          <a:p>
-            <a:pPr>
-              <a:defRPr sz="2200"/>
-            </a:pPr>
-            <a:r>
-              <a:t>Open folder PROJECT3.</a:t>
-            </a:r>
-          </a:p>
-          <a:p>
-            <a:pPr>
-              <a:defRPr sz="2200"/>
-            </a:pPr>
-            <a:r>
-              <a:t>Check folder contains Project-files, src, artifacts, data, sql.</a:t>
-            </a:r>
-          </a:p>
-          <a:p>
-            <a:pPr>
-              <a:defRPr sz="2200"/>
-            </a:pPr>
-            <a:r>
-              <a:t>Explain to students why structured folders improve teamwork.</a:t>
+              <a:rPr dirty="0"/>
+              <a:t>data/processed/rapido_processed.csv exists</a:t>
+            </a:r>
+          </a:p>
+          <a:p>
+            <a:pPr>
+              <a:defRPr sz="2200"/>
+            </a:pPr>
+            <a:r>
+              <a:rPr dirty="0"/>
+              <a:t>artifacts/reports/</a:t>
+            </a:r>
+            <a:r>
+              <a:rPr dirty="0" err="1"/>
+              <a:t>eda</a:t>
+            </a:r>
+            <a:r>
+              <a:rPr dirty="0"/>
+              <a:t> contains EDA plots and summaries</a:t>
+            </a:r>
+          </a:p>
+          <a:p>
+            <a:pPr>
+              <a:defRPr sz="2200"/>
+            </a:pPr>
+            <a:r>
+              <a:rPr dirty="0"/>
+              <a:t>artifacts/models contains 4 model files</a:t>
+            </a:r>
+          </a:p>
+          <a:p>
+            <a:pPr>
+              <a:defRPr sz="2200"/>
+            </a:pPr>
+            <a:r>
+              <a:rPr dirty="0"/>
+              <a:t>artifacts/reports/</a:t>
+            </a:r>
+            <a:r>
+              <a:rPr dirty="0" err="1"/>
+              <a:t>metrics.json</a:t>
+            </a:r>
+            <a:r>
+              <a:rPr dirty="0"/>
+              <a:t> exists</a:t>
+            </a:r>
+          </a:p>
+          <a:p>
+            <a:pPr>
+              <a:defRPr sz="2200"/>
+            </a:pPr>
+            <a:r>
+              <a:rPr dirty="0" err="1"/>
+              <a:t>sql</a:t>
+            </a:r>
+            <a:r>
+              <a:rPr dirty="0"/>
+              <a:t>/</a:t>
+            </a:r>
+            <a:r>
+              <a:rPr dirty="0" err="1"/>
+              <a:t>rapido.db</a:t>
+            </a:r>
+            <a:r>
+              <a:rPr dirty="0"/>
+              <a:t> exists</a:t>
             </a:r>
           </a:p>
         </p:txBody>
@@ -3492,47 +3507,43 @@
           <a:lstStyle/>
           <a:p>
             <a:r>
-              <a:t>Step 2: Install Required Packages</a:t>
-            </a:r>
-          </a:p>
-        </p:txBody>
-      </p:sp>
-      <p:sp>
-        <p:nvSpPr>
-          <p:cNvPr id="3" name="Content Placeholder 2"/>
-          <p:cNvSpPr>
-            <a:spLocks noGrp="1"/>
-          </p:cNvSpPr>
-          <p:nvPr>
-            <p:ph idx="1"/>
-          </p:nvPr>
-        </p:nvSpPr>
-        <p:spPr/>
-        <p:txBody>
-          <a:bodyPr/>
-          <a:lstStyle/>
-          <a:p>
-            <a:pPr>
-              <a:defRPr sz="2200"/>
-            </a:pPr>
-            <a:r>
-              <a:t>Run pip install -r requirements.txt</a:t>
-            </a:r>
-          </a:p>
-          <a:p>
-            <a:pPr>
-              <a:defRPr sz="2200"/>
-            </a:pPr>
-            <a:r>
-              <a:t>Explain that dependencies are libraries our code needs.</a:t>
-            </a:r>
-          </a:p>
-          <a:p>
-            <a:pPr>
-              <a:defRPr sz="2200"/>
-            </a:pPr>
-            <a:r>
-              <a:t>If any error appears, read first red line and fix one issue at a time.</a:t>
+              <a:t>Part 4</a:t>
+            </a:r>
+          </a:p>
+        </p:txBody>
+      </p:sp>
+      <p:sp>
+        <p:nvSpPr>
+          <p:cNvPr id="3" name="TextBox 2"/>
+          <p:cNvSpPr txBox="1"/>
+          <p:nvPr/>
+        </p:nvSpPr>
+        <p:spPr>
+          <a:xfrm>
+            <a:off x="914400" y="2011680"/>
+            <a:ext cx="6856108" cy="523220"/>
+          </a:xfrm>
+          <a:prstGeom prst="rect">
+            <a:avLst/>
+          </a:prstGeom>
+          <a:noFill/>
+        </p:spPr>
+        <p:txBody>
+          <a:bodyPr wrap="none">
+            <a:spAutoFit/>
+          </a:bodyPr>
+          <a:lstStyle/>
+          <a:p>
+            <a:pPr>
+              <a:defRPr sz="2800"/>
+            </a:pPr>
+            <a:r>
+              <a:rPr lang="en-US" dirty="0"/>
+              <a:t>P</a:t>
+            </a:r>
+            <a:r>
+              <a:rPr dirty="0"/>
+              <a:t>reprocessing and feature engineering deeply</a:t>
             </a:r>
           </a:p>
         </p:txBody>
@@ -3578,7 +3589,8 @@
           <a:lstStyle/>
           <a:p>
             <a:r>
-              <a:t>Step 3: Run Full Pipeline</a:t>
+              <a:rPr dirty="0"/>
+              <a:t>Data Cleaning</a:t>
             </a:r>
           </a:p>
         </p:txBody>
@@ -3602,23 +3614,43 @@
               <a:defRPr sz="2200"/>
             </a:pPr>
             <a:r>
-              <a:t>Run python -m src.run_pipeline</a:t>
-            </a:r>
-          </a:p>
-          <a:p>
-            <a:pPr>
-              <a:defRPr sz="2200"/>
-            </a:pPr>
-            <a:r>
-              <a:t>This runs cleaning, feature engineering, training, and SQL export.</a:t>
-            </a:r>
-          </a:p>
-          <a:p>
-            <a:pPr>
-              <a:defRPr sz="2200"/>
-            </a:pPr>
-            <a:r>
-              <a:t>Expected output includes model files and metrics report.</a:t>
+              <a:rPr dirty="0"/>
+              <a:t>Merged date and time into </a:t>
+            </a:r>
+            <a:r>
+              <a:rPr dirty="0" err="1"/>
+              <a:t>booking_datetime</a:t>
+            </a:r>
+            <a:r>
+              <a:rPr dirty="0"/>
+              <a:t>.</a:t>
+            </a:r>
+          </a:p>
+          <a:p>
+            <a:pPr>
+              <a:defRPr sz="2200"/>
+            </a:pPr>
+            <a:r>
+              <a:rPr dirty="0"/>
+              <a:t>Filled missing actual ride time using estimated ride time.</a:t>
+            </a:r>
+          </a:p>
+          <a:p>
+            <a:pPr>
+              <a:defRPr sz="2200"/>
+            </a:pPr>
+            <a:r>
+              <a:rPr dirty="0"/>
+              <a:t>Filled missing incomplete ride reason with None.</a:t>
+            </a:r>
+          </a:p>
+          <a:p>
+            <a:pPr>
+              <a:defRPr sz="2200"/>
+            </a:pPr>
+            <a:r>
+              <a:rPr dirty="0"/>
+              <a:t>Merged all source tables using keys and time features.</a:t>
             </a:r>
           </a:p>
         </p:txBody>
@@ -3660,23 +3692,18 @@
         </p:nvSpPr>
         <p:spPr/>
         <p:txBody>
-          <a:bodyPr>
-            <a:normAutofit/>
-          </a:bodyPr>
-          <a:lstStyle/>
-          <a:p>
-            <a:r>
-              <a:rPr dirty="0"/>
-              <a:t>What</a:t>
+          <a:bodyPr/>
+          <a:lstStyle/>
+          <a:p>
+            <a:r>
+              <a:rPr dirty="0"/>
+              <a:t>EDA</a:t>
             </a:r>
             <a:r>
               <a:rPr lang="en-US" dirty="0"/>
-              <a:t> </a:t>
-            </a:r>
-            <a:r>
-              <a:rPr dirty="0"/>
-              <a:t>Should Verify After Pipeline</a:t>
-            </a:r>
+              <a:t> : Exploratory Data Analysis</a:t>
+            </a:r>
+            <a:endParaRPr dirty="0"/>
           </a:p>
         </p:txBody>
       </p:sp>
@@ -3700,54 +3727,67 @@
             </a:pPr>
             <a:r>
               <a:rPr dirty="0"/>
-              <a:t>data/processed/rapido_processed.csv exists</a:t>
-            </a:r>
-          </a:p>
-          <a:p>
-            <a:pPr>
-              <a:defRPr sz="2200"/>
-            </a:pPr>
-            <a:r>
-              <a:rPr dirty="0"/>
-              <a:t>artifacts/models contains 4 model files</a:t>
-            </a:r>
-          </a:p>
-          <a:p>
-            <a:pPr>
-              <a:defRPr sz="2200"/>
-            </a:pPr>
-            <a:r>
-              <a:rPr dirty="0"/>
-              <a:t>artifacts/reports/</a:t>
+              <a:t>Runs on raw and cleaned data, before feature engineering.</a:t>
+            </a:r>
+          </a:p>
+          <a:p>
+            <a:pPr>
+              <a:defRPr sz="2200"/>
+            </a:pPr>
+            <a:r>
+              <a:rPr dirty="0"/>
+              <a:t>Statistical summary: shape, nulls, describe, skewness, class balance.</a:t>
+            </a:r>
+          </a:p>
+          <a:p>
+            <a:pPr>
+              <a:defRPr sz="2200"/>
+            </a:pPr>
+            <a:r>
+              <a:rPr dirty="0"/>
+              <a:t>Plots: histogram, box, bar/pie, scatter, correlation heatmap, pair plot.</a:t>
+            </a:r>
+          </a:p>
+          <a:p>
+            <a:pPr>
+              <a:defRPr sz="2200"/>
+            </a:pPr>
+            <a:r>
+              <a:rPr dirty="0"/>
+              <a:t>What we saw here justified the engineered features we built.</a:t>
+            </a:r>
+          </a:p>
+          <a:p>
+            <a:pPr>
+              <a:defRPr sz="2200"/>
+            </a:pPr>
+            <a:r>
+              <a:rPr dirty="0"/>
+              <a:t>Saved under artifacts/reports/</a:t>
             </a:r>
             <a:r>
               <a:rPr dirty="0" err="1"/>
-              <a:t>metrics.json</a:t>
-            </a:r>
-            <a:r>
-              <a:rPr dirty="0"/>
-              <a:t> exists</a:t>
-            </a:r>
-          </a:p>
-          <a:p>
-            <a:pPr>
-              <a:defRPr sz="2200"/>
-            </a:pPr>
+              <a:t>eda</a:t>
+            </a:r>
+            <a:r>
+              <a:rPr dirty="0"/>
+              <a:t> (</a:t>
+            </a:r>
             <a:r>
               <a:rPr dirty="0" err="1"/>
-              <a:t>sql</a:t>
-            </a:r>
-            <a:r>
-              <a:rPr dirty="0"/>
-              <a:t>/</a:t>
+              <a:t>before_cleaning</a:t>
+            </a:r>
+            <a:r>
+              <a:rPr dirty="0"/>
+              <a:t> and </a:t>
             </a:r>
             <a:r>
               <a:rPr dirty="0" err="1"/>
-              <a:t>rapido.db</a:t>
-            </a:r>
-            <a:r>
-              <a:rPr dirty="0"/>
-              <a:t> exists</a:t>
+              <a:t>after_cleaning</a:t>
+            </a:r>
+            <a:r>
+              <a:rPr dirty="0"/>
+              <a:t>).</a:t>
             </a:r>
           </a:p>
         </p:txBody>
@@ -3793,38 +3833,110 @@
           <a:lstStyle/>
           <a:p>
             <a:r>
-              <a:t>Part 4</a:t>
-            </a:r>
-          </a:p>
-        </p:txBody>
-      </p:sp>
-      <p:sp>
-        <p:nvSpPr>
-          <p:cNvPr id="3" name="TextBox 2"/>
-          <p:cNvSpPr txBox="1"/>
-          <p:nvPr/>
-        </p:nvSpPr>
-        <p:spPr>
-          <a:xfrm>
-            <a:off x="914400" y="2011680"/>
-            <a:ext cx="10058400" cy="2286000"/>
-          </a:xfrm>
-          <a:prstGeom prst="rect">
-            <a:avLst/>
-          </a:prstGeom>
-          <a:noFill/>
-        </p:spPr>
-        <p:txBody>
-          <a:bodyPr wrap="none">
-            <a:spAutoFit/>
-          </a:bodyPr>
-          <a:lstStyle/>
-          <a:p>
-            <a:pPr>
-              <a:defRPr sz="2800"/>
-            </a:pPr>
-            <a:r>
-              <a:t>Teach preprocessing and feature engineering deeply</a:t>
+              <a:rPr dirty="0"/>
+              <a:t>Feature Engineering</a:t>
+            </a:r>
+          </a:p>
+        </p:txBody>
+      </p:sp>
+      <p:sp>
+        <p:nvSpPr>
+          <p:cNvPr id="3" name="Content Placeholder 2"/>
+          <p:cNvSpPr>
+            <a:spLocks noGrp="1"/>
+          </p:cNvSpPr>
+          <p:nvPr>
+            <p:ph idx="1"/>
+          </p:nvPr>
+        </p:nvSpPr>
+        <p:spPr/>
+        <p:txBody>
+          <a:bodyPr/>
+          <a:lstStyle/>
+          <a:p>
+            <a:pPr>
+              <a:defRPr sz="2200"/>
+            </a:pPr>
+            <a:r>
+              <a:rPr dirty="0" err="1"/>
+              <a:t>fare_per_km</a:t>
+            </a:r>
+            <a:r>
+              <a:rPr dirty="0"/>
+              <a:t> helps compare cost efficiency across rides.</a:t>
+            </a:r>
+          </a:p>
+          <a:p>
+            <a:pPr>
+              <a:defRPr sz="2200"/>
+            </a:pPr>
+            <a:r>
+              <a:rPr dirty="0" err="1"/>
+              <a:t>fare_per_min</a:t>
+            </a:r>
+            <a:r>
+              <a:rPr dirty="0"/>
+              <a:t> captures speed and traffic pressure.</a:t>
+            </a:r>
+          </a:p>
+          <a:p>
+            <a:pPr>
+              <a:defRPr sz="2200"/>
+            </a:pPr>
+            <a:r>
+              <a:rPr dirty="0" err="1"/>
+              <a:t>rush_hour_flag</a:t>
+            </a:r>
+            <a:r>
+              <a:rPr dirty="0"/>
+              <a:t> marks high-congestion hours.</a:t>
+            </a:r>
+          </a:p>
+          <a:p>
+            <a:pPr>
+              <a:defRPr sz="2200"/>
+            </a:pPr>
+            <a:r>
+              <a:rPr dirty="0" err="1"/>
+              <a:t>long_distance_flag</a:t>
+            </a:r>
+            <a:r>
+              <a:rPr dirty="0"/>
+              <a:t> helps distinguish trip types.</a:t>
+            </a:r>
+          </a:p>
+          <a:p>
+            <a:pPr>
+              <a:defRPr sz="2200"/>
+            </a:pPr>
+            <a:r>
+              <a:rPr dirty="0" err="1"/>
+              <a:t>city_pair</a:t>
+            </a:r>
+            <a:r>
+              <a:rPr dirty="0"/>
+              <a:t> captures route-level behavior.</a:t>
+            </a:r>
+          </a:p>
+          <a:p>
+            <a:pPr>
+              <a:defRPr sz="2200"/>
+            </a:pPr>
+            <a:r>
+              <a:rPr dirty="0" err="1"/>
+              <a:t>driver_reliability_score</a:t>
+            </a:r>
+            <a:r>
+              <a:rPr dirty="0"/>
+              <a:t> and </a:t>
+            </a:r>
+            <a:r>
+              <a:rPr dirty="0" err="1"/>
+              <a:t>customer_loyalty_score</a:t>
+            </a:r>
+            <a:r>
+              <a:rPr dirty="0"/>
+              <a:t> summarize patterns.</a:t>
             </a:r>
           </a:p>
         </p:txBody>
@@ -3870,55 +3982,38 @@
           <a:lstStyle/>
           <a:p>
             <a:r>
-              <a:t>Data Cleaning: What We Did</a:t>
-            </a:r>
-          </a:p>
-        </p:txBody>
-      </p:sp>
-      <p:sp>
-        <p:nvSpPr>
-          <p:cNvPr id="3" name="Content Placeholder 2"/>
-          <p:cNvSpPr>
-            <a:spLocks noGrp="1"/>
-          </p:cNvSpPr>
-          <p:nvPr>
-            <p:ph idx="1"/>
-          </p:nvPr>
-        </p:nvSpPr>
-        <p:spPr/>
-        <p:txBody>
-          <a:bodyPr/>
-          <a:lstStyle/>
-          <a:p>
-            <a:pPr>
-              <a:defRPr sz="2200"/>
-            </a:pPr>
-            <a:r>
-              <a:t>Merged date and time into booking_datetime.</a:t>
-            </a:r>
-          </a:p>
-          <a:p>
-            <a:pPr>
-              <a:defRPr sz="2200"/>
-            </a:pPr>
-            <a:r>
-              <a:t>Filled missing actual ride time using estimated ride time.</a:t>
-            </a:r>
-          </a:p>
-          <a:p>
-            <a:pPr>
-              <a:defRPr sz="2200"/>
-            </a:pPr>
-            <a:r>
-              <a:t>Filled missing incomplete ride reason with None.</a:t>
-            </a:r>
-          </a:p>
-          <a:p>
-            <a:pPr>
-              <a:defRPr sz="2200"/>
-            </a:pPr>
-            <a:r>
-              <a:t>Merged all source tables using keys and time features.</a:t>
+              <a:t>Part 5</a:t>
+            </a:r>
+          </a:p>
+        </p:txBody>
+      </p:sp>
+      <p:sp>
+        <p:nvSpPr>
+          <p:cNvPr id="3" name="TextBox 2"/>
+          <p:cNvSpPr txBox="1"/>
+          <p:nvPr/>
+        </p:nvSpPr>
+        <p:spPr>
+          <a:xfrm>
+            <a:off x="914400" y="2011680"/>
+            <a:ext cx="10058400" cy="2286000"/>
+          </a:xfrm>
+          <a:prstGeom prst="rect">
+            <a:avLst/>
+          </a:prstGeom>
+          <a:noFill/>
+        </p:spPr>
+        <p:txBody>
+          <a:bodyPr wrap="none">
+            <a:spAutoFit/>
+          </a:bodyPr>
+          <a:lstStyle/>
+          <a:p>
+            <a:pPr>
+              <a:defRPr sz="2800"/>
+            </a:pPr>
+            <a:r>
+              <a:t>Model training and evaluation interpretation</a:t>
             </a:r>
           </a:p>
         </p:txBody>
@@ -3964,7 +4059,7 @@
           <a:lstStyle/>
           <a:p>
             <a:r>
-              <a:t>Feature Engineering: Why It Matters</a:t>
+              <a:t>Modeling Pipeline Architecture</a:t>
             </a:r>
           </a:p>
         </p:txBody>
@@ -3988,47 +4083,31 @@
               <a:defRPr sz="2200"/>
             </a:pPr>
             <a:r>
-              <a:t>fare_per_km helps compare cost efficiency across rides.</a:t>
-            </a:r>
-          </a:p>
-          <a:p>
-            <a:pPr>
-              <a:defRPr sz="2200"/>
-            </a:pPr>
-            <a:r>
-              <a:t>fare_per_min captures speed and traffic pressure.</a:t>
-            </a:r>
-          </a:p>
-          <a:p>
-            <a:pPr>
-              <a:defRPr sz="2200"/>
-            </a:pPr>
-            <a:r>
-              <a:t>rush_hour_flag marks high-congestion hours.</a:t>
-            </a:r>
-          </a:p>
-          <a:p>
-            <a:pPr>
-              <a:defRPr sz="2200"/>
-            </a:pPr>
-            <a:r>
-              <a:t>long_distance_flag helps distinguish trip types.</a:t>
-            </a:r>
-          </a:p>
-          <a:p>
-            <a:pPr>
-              <a:defRPr sz="2200"/>
-            </a:pPr>
-            <a:r>
-              <a:t>city_pair captures route-level behavior.</a:t>
-            </a:r>
-          </a:p>
-          <a:p>
-            <a:pPr>
-              <a:defRPr sz="2200"/>
-            </a:pPr>
-            <a:r>
-              <a:t>driver_reliability_score and customer_loyalty_score summarize patterns.</a:t>
+              <a:t>Split data into train and test sets.</a:t>
+            </a:r>
+          </a:p>
+          <a:p>
+            <a:pPr>
+              <a:defRPr sz="2200"/>
+            </a:pPr>
+            <a:r>
+              <a:t>Numeric columns: median imputation.</a:t>
+            </a:r>
+          </a:p>
+          <a:p>
+            <a:pPr>
+              <a:defRPr sz="2200"/>
+            </a:pPr>
+            <a:r>
+              <a:t>Categorical columns: most frequent imputation + one hot encoding.</a:t>
+            </a:r>
+          </a:p>
+          <a:p>
+            <a:pPr>
+              <a:defRPr sz="2200"/>
+            </a:pPr>
+            <a:r>
+              <a:t>Train Random Forest models for baseline performance.</a:t>
             </a:r>
           </a:p>
         </p:txBody>
@@ -4075,7 +4154,7 @@
           <a:p>
             <a:r>
               <a:rPr dirty="0"/>
-              <a:t>Leakage</a:t>
+              <a:t>Explain Classification Metrics</a:t>
             </a:r>
           </a:p>
         </p:txBody>
@@ -4100,34 +4179,34 @@
             </a:pPr>
             <a:r>
               <a:rPr dirty="0"/>
-              <a:t>Leakage means model sees future or answer-like information.</a:t>
-            </a:r>
-          </a:p>
-          <a:p>
-            <a:pPr>
-              <a:defRPr sz="2200"/>
-            </a:pPr>
-            <a:r>
-              <a:rPr dirty="0"/>
-              <a:t>If leakage exists, scores look very high but fail in real life.</a:t>
-            </a:r>
-          </a:p>
-          <a:p>
-            <a:pPr>
-              <a:defRPr sz="2200"/>
-            </a:pPr>
-            <a:r>
-              <a:rPr dirty="0"/>
-              <a:t>Tell students: realistic model is better than perfect fake score.</a:t>
-            </a:r>
-          </a:p>
-          <a:p>
-            <a:pPr>
-              <a:defRPr sz="2200"/>
-            </a:pPr>
-            <a:r>
-              <a:rPr dirty="0"/>
-              <a:t>Always remove direct target proxies before final evaluation.</a:t>
+              <a:t>Accuracy: overall correct predictions percentage.</a:t>
+            </a:r>
+          </a:p>
+          <a:p>
+            <a:pPr>
+              <a:defRPr sz="2200"/>
+            </a:pPr>
+            <a:r>
+              <a:rPr dirty="0"/>
+              <a:t>F1 score: balance between precision and recall.</a:t>
+            </a:r>
+          </a:p>
+          <a:p>
+            <a:pPr>
+              <a:defRPr sz="2200"/>
+            </a:pPr>
+            <a:r>
+              <a:rPr dirty="0"/>
+              <a:t>AUC: ranking quality of risk probabilities.</a:t>
+            </a:r>
+          </a:p>
+          <a:p>
+            <a:pPr>
+              <a:defRPr sz="2200"/>
+            </a:pPr>
+            <a:r>
+              <a:rPr dirty="0"/>
+              <a:t>Confusion matrix: where model confuses classes.</a:t>
             </a:r>
           </a:p>
         </p:txBody>
@@ -4173,7 +4252,8 @@
           <a:lstStyle/>
           <a:p>
             <a:r>
-              <a:t>How To Use This Deck</a:t>
+              <a:rPr dirty="0"/>
+              <a:t>Project</a:t>
             </a:r>
           </a:p>
         </p:txBody>
@@ -4197,31 +4277,35 @@
               <a:defRPr sz="2200"/>
             </a:pPr>
             <a:r>
-              <a:t>This deck assumes students are complete beginners.</a:t>
-            </a:r>
-          </a:p>
-          <a:p>
-            <a:pPr>
-              <a:defRPr sz="2200"/>
-            </a:pPr>
-            <a:r>
-              <a:t>Teach one slide, then run the exact action in VS Code or terminal.</a:t>
-            </a:r>
-          </a:p>
-          <a:p>
-            <a:pPr>
-              <a:defRPr sz="2200"/>
-            </a:pPr>
-            <a:r>
-              <a:t>Pause after every major step and ask students to verify output.</a:t>
-            </a:r>
-          </a:p>
-          <a:p>
-            <a:pPr>
-              <a:defRPr sz="2200"/>
-            </a:pPr>
-            <a:r>
-              <a:t>Main goal: students should understand both why and how.</a:t>
+              <a:rPr dirty="0"/>
+              <a:t>Rapido gets many bookings every day.</a:t>
+            </a:r>
+          </a:p>
+          <a:p>
+            <a:pPr>
+              <a:defRPr sz="2200"/>
+            </a:pPr>
+            <a:r>
+              <a:rPr dirty="0"/>
+              <a:t>Some rides get cancelled, some are delayed, and fares are hard to predict.</a:t>
+            </a:r>
+          </a:p>
+          <a:p>
+            <a:pPr>
+              <a:defRPr sz="2200"/>
+            </a:pPr>
+            <a:r>
+              <a:rPr dirty="0"/>
+              <a:t>If we predict these early, operations can take action before problems happen.</a:t>
+            </a:r>
+          </a:p>
+          <a:p>
+            <a:pPr>
+              <a:defRPr sz="2200"/>
+            </a:pPr>
+            <a:r>
+              <a:rPr dirty="0"/>
+              <a:t>Machine learning helps us convert past trip data into predictions.</a:t>
             </a:r>
           </a:p>
         </p:txBody>
@@ -4267,38 +4351,60 @@
           <a:lstStyle/>
           <a:p>
             <a:r>
-              <a:t>Part 5</a:t>
-            </a:r>
-          </a:p>
-        </p:txBody>
-      </p:sp>
-      <p:sp>
-        <p:nvSpPr>
-          <p:cNvPr id="3" name="TextBox 2"/>
-          <p:cNvSpPr txBox="1"/>
-          <p:nvPr/>
-        </p:nvSpPr>
-        <p:spPr>
-          <a:xfrm>
-            <a:off x="914400" y="2011680"/>
-            <a:ext cx="10058400" cy="2286000"/>
-          </a:xfrm>
-          <a:prstGeom prst="rect">
-            <a:avLst/>
-          </a:prstGeom>
-          <a:noFill/>
-        </p:spPr>
-        <p:txBody>
-          <a:bodyPr wrap="none">
-            <a:spAutoFit/>
-          </a:bodyPr>
-          <a:lstStyle/>
-          <a:p>
-            <a:pPr>
-              <a:defRPr sz="2800"/>
-            </a:pPr>
-            <a:r>
-              <a:t>Model training and evaluation interpretation</a:t>
+              <a:rPr dirty="0"/>
+              <a:t>Explain Regression Metrics</a:t>
+            </a:r>
+          </a:p>
+        </p:txBody>
+      </p:sp>
+      <p:sp>
+        <p:nvSpPr>
+          <p:cNvPr id="3" name="Content Placeholder 2"/>
+          <p:cNvSpPr>
+            <a:spLocks noGrp="1"/>
+          </p:cNvSpPr>
+          <p:nvPr>
+            <p:ph idx="1"/>
+          </p:nvPr>
+        </p:nvSpPr>
+        <p:spPr/>
+        <p:txBody>
+          <a:bodyPr/>
+          <a:lstStyle/>
+          <a:p>
+            <a:pPr>
+              <a:defRPr sz="2200"/>
+            </a:pPr>
+            <a:r>
+              <a:rPr dirty="0"/>
+              <a:t>MAE: average absolute error in fare units.</a:t>
+            </a:r>
+          </a:p>
+          <a:p>
+            <a:pPr>
+              <a:defRPr sz="2200"/>
+            </a:pPr>
+            <a:r>
+              <a:rPr dirty="0"/>
+              <a:t>RMSE: gives higher penalty to big errors.</a:t>
+            </a:r>
+          </a:p>
+          <a:p>
+            <a:pPr>
+              <a:defRPr sz="2200"/>
+            </a:pPr>
+            <a:r>
+              <a:rPr dirty="0"/>
+              <a:t>R2: how much variance model explains.</a:t>
+            </a:r>
+          </a:p>
+          <a:p>
+            <a:pPr>
+              <a:defRPr sz="2200"/>
+            </a:pPr>
+            <a:r>
+              <a:rPr dirty="0"/>
+              <a:t>Also compare prediction error percentage against actual fare.</a:t>
             </a:r>
           </a:p>
         </p:txBody>
@@ -4344,55 +4450,39 @@
           <a:lstStyle/>
           <a:p>
             <a:r>
-              <a:t>Modeling Pipeline Architecture</a:t>
-            </a:r>
-          </a:p>
-        </p:txBody>
-      </p:sp>
-      <p:sp>
-        <p:nvSpPr>
-          <p:cNvPr id="3" name="Content Placeholder 2"/>
-          <p:cNvSpPr>
-            <a:spLocks noGrp="1"/>
-          </p:cNvSpPr>
-          <p:nvPr>
-            <p:ph idx="1"/>
-          </p:nvPr>
-        </p:nvSpPr>
-        <p:spPr/>
-        <p:txBody>
-          <a:bodyPr/>
-          <a:lstStyle/>
-          <a:p>
-            <a:pPr>
-              <a:defRPr sz="2200"/>
-            </a:pPr>
-            <a:r>
-              <a:t>Split data into train and test sets.</a:t>
-            </a:r>
-          </a:p>
-          <a:p>
-            <a:pPr>
-              <a:defRPr sz="2200"/>
-            </a:pPr>
-            <a:r>
-              <a:t>Numeric columns: median imputation.</a:t>
-            </a:r>
-          </a:p>
-          <a:p>
-            <a:pPr>
-              <a:defRPr sz="2200"/>
-            </a:pPr>
-            <a:r>
-              <a:t>Categorical columns: most frequent imputation + one hot encoding.</a:t>
-            </a:r>
-          </a:p>
-          <a:p>
-            <a:pPr>
-              <a:defRPr sz="2200"/>
-            </a:pPr>
-            <a:r>
-              <a:t>Train Random Forest models for baseline performance.</a:t>
+              <a:t>Part 6</a:t>
+            </a:r>
+          </a:p>
+        </p:txBody>
+      </p:sp>
+      <p:sp>
+        <p:nvSpPr>
+          <p:cNvPr id="3" name="TextBox 2"/>
+          <p:cNvSpPr txBox="1"/>
+          <p:nvPr/>
+        </p:nvSpPr>
+        <p:spPr>
+          <a:xfrm>
+            <a:off x="457200" y="1435926"/>
+            <a:ext cx="10058400" cy="2286000"/>
+          </a:xfrm>
+          <a:prstGeom prst="rect">
+            <a:avLst/>
+          </a:prstGeom>
+          <a:noFill/>
+        </p:spPr>
+        <p:txBody>
+          <a:bodyPr wrap="none">
+            <a:spAutoFit/>
+          </a:bodyPr>
+          <a:lstStyle/>
+          <a:p>
+            <a:pPr>
+              <a:defRPr sz="2800"/>
+            </a:pPr>
+            <a:r>
+              <a:rPr dirty="0"/>
+              <a:t>Visualization, dashboard, and stakeholder communication</a:t>
             </a:r>
           </a:p>
         </p:txBody>
@@ -4438,7 +4528,7 @@
           <a:lstStyle/>
           <a:p>
             <a:r>
-              <a:t>How To Explain Classification Metrics</a:t>
+              <a:t>Step 4: Run Streamlit App</a:t>
             </a:r>
           </a:p>
         </p:txBody>
@@ -4462,31 +4552,31 @@
               <a:defRPr sz="2200"/>
             </a:pPr>
             <a:r>
-              <a:t>Accuracy: overall correct predictions percentage.</a:t>
-            </a:r>
-          </a:p>
-          <a:p>
-            <a:pPr>
-              <a:defRPr sz="2200"/>
-            </a:pPr>
-            <a:r>
-              <a:t>F1 score: balance between precision and recall.</a:t>
-            </a:r>
-          </a:p>
-          <a:p>
-            <a:pPr>
-              <a:defRPr sz="2200"/>
-            </a:pPr>
-            <a:r>
-              <a:t>AUC: ranking quality of risk probabilities.</a:t>
-            </a:r>
-          </a:p>
-          <a:p>
-            <a:pPr>
-              <a:defRPr sz="2200"/>
-            </a:pPr>
-            <a:r>
-              <a:t>Confusion matrix: where model confuses classes.</a:t>
+              <a:t>Run streamlit run app.py</a:t>
+            </a:r>
+          </a:p>
+          <a:p>
+            <a:pPr>
+              <a:defRPr sz="2200"/>
+            </a:pPr>
+            <a:r>
+              <a:t>Tab 1: Business KPIs and cancellation-by-hour trend.</a:t>
+            </a:r>
+          </a:p>
+          <a:p>
+            <a:pPr>
+              <a:defRPr sz="2200"/>
+            </a:pPr>
+            <a:r>
+              <a:t>Tab 2: Single booking prediction for live demo.</a:t>
+            </a:r>
+          </a:p>
+          <a:p>
+            <a:pPr>
+              <a:defRPr sz="2200"/>
+            </a:pPr>
+            <a:r>
+              <a:t>Tab 3: Batch CSV prediction and download output.</a:t>
             </a:r>
           </a:p>
         </p:txBody>
@@ -4532,7 +4622,8 @@
           <a:lstStyle/>
           <a:p>
             <a:r>
-              <a:t>How To Explain Regression Metrics</a:t>
+              <a:rPr dirty="0"/>
+              <a:t>Operational Interventions</a:t>
             </a:r>
           </a:p>
         </p:txBody>
@@ -4556,462 +4647,6 @@
               <a:defRPr sz="2200"/>
             </a:pPr>
             <a:r>
-              <a:t>MAE: average absolute error in fare units.</a:t>
-            </a:r>
-          </a:p>
-          <a:p>
-            <a:pPr>
-              <a:defRPr sz="2200"/>
-            </a:pPr>
-            <a:r>
-              <a:t>RMSE: gives higher penalty to big errors.</a:t>
-            </a:r>
-          </a:p>
-          <a:p>
-            <a:pPr>
-              <a:defRPr sz="2200"/>
-            </a:pPr>
-            <a:r>
-              <a:t>R2: how much variance model explains.</a:t>
-            </a:r>
-          </a:p>
-          <a:p>
-            <a:pPr>
-              <a:defRPr sz="2200"/>
-            </a:pPr>
-            <a:r>
-              <a:t>Also compare prediction error percentage against actual fare.</a:t>
-            </a:r>
-          </a:p>
-        </p:txBody>
-      </p:sp>
-    </p:spTree>
-  </p:cSld>
-  <p:clrMapOvr>
-    <a:masterClrMapping/>
-  </p:clrMapOvr>
-</p:sld>
-</file>
-
-<file path=ppt/slides/slide24.xml><?xml version="1.0" encoding="utf-8"?>
-<p:sld xmlns:a="http://schemas.openxmlformats.org/drawingml/2006/main" xmlns:r="http://schemas.openxmlformats.org/officeDocument/2006/relationships" xmlns:p="http://schemas.openxmlformats.org/presentationml/2006/main">
-  <p:cSld>
-    <p:spTree>
-      <p:nvGrpSpPr>
-        <p:cNvPr id="1" name=""/>
-        <p:cNvGrpSpPr/>
-        <p:nvPr/>
-      </p:nvGrpSpPr>
-      <p:grpSpPr>
-        <a:xfrm>
-          <a:off x="0" y="0"/>
-          <a:ext cx="0" cy="0"/>
-          <a:chOff x="0" y="0"/>
-          <a:chExt cx="0" cy="0"/>
-        </a:xfrm>
-      </p:grpSpPr>
-      <p:sp>
-        <p:nvSpPr>
-          <p:cNvPr id="2" name="Title 1"/>
-          <p:cNvSpPr>
-            <a:spLocks noGrp="1"/>
-          </p:cNvSpPr>
-          <p:nvPr>
-            <p:ph type="title"/>
-          </p:nvPr>
-        </p:nvSpPr>
-        <p:spPr/>
-        <p:txBody>
-          <a:bodyPr/>
-          <a:lstStyle/>
-          <a:p>
-            <a:r>
-              <a:t>Classroom Exercise: Read metrics.json</a:t>
-            </a:r>
-          </a:p>
-        </p:txBody>
-      </p:sp>
-      <p:sp>
-        <p:nvSpPr>
-          <p:cNvPr id="3" name="Content Placeholder 2"/>
-          <p:cNvSpPr>
-            <a:spLocks noGrp="1"/>
-          </p:cNvSpPr>
-          <p:nvPr>
-            <p:ph idx="1"/>
-          </p:nvPr>
-        </p:nvSpPr>
-        <p:spPr/>
-        <p:txBody>
-          <a:bodyPr/>
-          <a:lstStyle/>
-          <a:p>
-            <a:pPr>
-              <a:defRPr sz="2200"/>
-            </a:pPr>
-            <a:r>
-              <a:t>Open metrics file after training.</a:t>
-            </a:r>
-          </a:p>
-          <a:p>
-            <a:pPr>
-              <a:defRPr sz="2200"/>
-            </a:pPr>
-            <a:r>
-              <a:t>Ask students to identify best and weakest model.</a:t>
-            </a:r>
-          </a:p>
-          <a:p>
-            <a:pPr>
-              <a:defRPr sz="2200"/>
-            </a:pPr>
-            <a:r>
-              <a:t>Ask what business action each metric supports.</a:t>
-            </a:r>
-          </a:p>
-          <a:p>
-            <a:pPr>
-              <a:defRPr sz="2200"/>
-            </a:pPr>
-            <a:r>
-              <a:t>Discuss why extremely high metrics should be questioned.</a:t>
-            </a:r>
-          </a:p>
-        </p:txBody>
-      </p:sp>
-    </p:spTree>
-  </p:cSld>
-  <p:clrMapOvr>
-    <a:masterClrMapping/>
-  </p:clrMapOvr>
-</p:sld>
-</file>
-
-<file path=ppt/slides/slide25.xml><?xml version="1.0" encoding="utf-8"?>
-<p:sld xmlns:a="http://schemas.openxmlformats.org/drawingml/2006/main" xmlns:r="http://schemas.openxmlformats.org/officeDocument/2006/relationships" xmlns:p="http://schemas.openxmlformats.org/presentationml/2006/main">
-  <p:cSld>
-    <p:spTree>
-      <p:nvGrpSpPr>
-        <p:cNvPr id="1" name=""/>
-        <p:cNvGrpSpPr/>
-        <p:nvPr/>
-      </p:nvGrpSpPr>
-      <p:grpSpPr>
-        <a:xfrm>
-          <a:off x="0" y="0"/>
-          <a:ext cx="0" cy="0"/>
-          <a:chOff x="0" y="0"/>
-          <a:chExt cx="0" cy="0"/>
-        </a:xfrm>
-      </p:grpSpPr>
-      <p:sp>
-        <p:nvSpPr>
-          <p:cNvPr id="2" name="Title 1"/>
-          <p:cNvSpPr>
-            <a:spLocks noGrp="1"/>
-          </p:cNvSpPr>
-          <p:nvPr>
-            <p:ph type="title"/>
-          </p:nvPr>
-        </p:nvSpPr>
-        <p:spPr/>
-        <p:txBody>
-          <a:bodyPr/>
-          <a:lstStyle/>
-          <a:p>
-            <a:r>
-              <a:t>Part 6</a:t>
-            </a:r>
-          </a:p>
-        </p:txBody>
-      </p:sp>
-      <p:sp>
-        <p:nvSpPr>
-          <p:cNvPr id="3" name="TextBox 2"/>
-          <p:cNvSpPr txBox="1"/>
-          <p:nvPr/>
-        </p:nvSpPr>
-        <p:spPr>
-          <a:xfrm>
-            <a:off x="914400" y="2011680"/>
-            <a:ext cx="7772400" cy="954107"/>
-          </a:xfrm>
-          <a:prstGeom prst="rect">
-            <a:avLst/>
-          </a:prstGeom>
-          <a:noFill/>
-        </p:spPr>
-        <p:txBody>
-          <a:bodyPr wrap="square">
-            <a:spAutoFit/>
-          </a:bodyPr>
-          <a:lstStyle/>
-          <a:p>
-            <a:pPr>
-              <a:defRPr sz="2800"/>
-            </a:pPr>
-            <a:r>
-              <a:rPr dirty="0"/>
-              <a:t>Visualization, dashboard, and stakeholder communication</a:t>
-            </a:r>
-          </a:p>
-        </p:txBody>
-      </p:sp>
-    </p:spTree>
-  </p:cSld>
-  <p:clrMapOvr>
-    <a:masterClrMapping/>
-  </p:clrMapOvr>
-</p:sld>
-</file>
-
-<file path=ppt/slides/slide26.xml><?xml version="1.0" encoding="utf-8"?>
-<p:sld xmlns:a="http://schemas.openxmlformats.org/drawingml/2006/main" xmlns:r="http://schemas.openxmlformats.org/officeDocument/2006/relationships" xmlns:p="http://schemas.openxmlformats.org/presentationml/2006/main">
-  <p:cSld>
-    <p:spTree>
-      <p:nvGrpSpPr>
-        <p:cNvPr id="1" name=""/>
-        <p:cNvGrpSpPr/>
-        <p:nvPr/>
-      </p:nvGrpSpPr>
-      <p:grpSpPr>
-        <a:xfrm>
-          <a:off x="0" y="0"/>
-          <a:ext cx="0" cy="0"/>
-          <a:chOff x="0" y="0"/>
-          <a:chExt cx="0" cy="0"/>
-        </a:xfrm>
-      </p:grpSpPr>
-      <p:sp>
-        <p:nvSpPr>
-          <p:cNvPr id="2" name="Title 1"/>
-          <p:cNvSpPr>
-            <a:spLocks noGrp="1"/>
-          </p:cNvSpPr>
-          <p:nvPr>
-            <p:ph type="title"/>
-          </p:nvPr>
-        </p:nvSpPr>
-        <p:spPr/>
-        <p:txBody>
-          <a:bodyPr/>
-          <a:lstStyle/>
-          <a:p>
-            <a:r>
-              <a:t>Step 4: Run Streamlit App</a:t>
-            </a:r>
-          </a:p>
-        </p:txBody>
-      </p:sp>
-      <p:sp>
-        <p:nvSpPr>
-          <p:cNvPr id="3" name="Content Placeholder 2"/>
-          <p:cNvSpPr>
-            <a:spLocks noGrp="1"/>
-          </p:cNvSpPr>
-          <p:nvPr>
-            <p:ph idx="1"/>
-          </p:nvPr>
-        </p:nvSpPr>
-        <p:spPr/>
-        <p:txBody>
-          <a:bodyPr/>
-          <a:lstStyle/>
-          <a:p>
-            <a:pPr>
-              <a:defRPr sz="2200"/>
-            </a:pPr>
-            <a:r>
-              <a:t>Run streamlit run app.py</a:t>
-            </a:r>
-          </a:p>
-          <a:p>
-            <a:pPr>
-              <a:defRPr sz="2200"/>
-            </a:pPr>
-            <a:r>
-              <a:t>Tab 1: Business KPIs and cancellation-by-hour trend.</a:t>
-            </a:r>
-          </a:p>
-          <a:p>
-            <a:pPr>
-              <a:defRPr sz="2200"/>
-            </a:pPr>
-            <a:r>
-              <a:t>Tab 2: Single booking prediction for live demo.</a:t>
-            </a:r>
-          </a:p>
-          <a:p>
-            <a:pPr>
-              <a:defRPr sz="2200"/>
-            </a:pPr>
-            <a:r>
-              <a:t>Tab 3: Batch CSV prediction and download output.</a:t>
-            </a:r>
-          </a:p>
-        </p:txBody>
-      </p:sp>
-    </p:spTree>
-  </p:cSld>
-  <p:clrMapOvr>
-    <a:masterClrMapping/>
-  </p:clrMapOvr>
-</p:sld>
-</file>
-
-<file path=ppt/slides/slide27.xml><?xml version="1.0" encoding="utf-8"?>
-<p:sld xmlns:a="http://schemas.openxmlformats.org/drawingml/2006/main" xmlns:r="http://schemas.openxmlformats.org/officeDocument/2006/relationships" xmlns:p="http://schemas.openxmlformats.org/presentationml/2006/main">
-  <p:cSld>
-    <p:spTree>
-      <p:nvGrpSpPr>
-        <p:cNvPr id="1" name=""/>
-        <p:cNvGrpSpPr/>
-        <p:nvPr/>
-      </p:nvGrpSpPr>
-      <p:grpSpPr>
-        <a:xfrm>
-          <a:off x="0" y="0"/>
-          <a:ext cx="0" cy="0"/>
-          <a:chOff x="0" y="0"/>
-          <a:chExt cx="0" cy="0"/>
-        </a:xfrm>
-      </p:grpSpPr>
-      <p:sp>
-        <p:nvSpPr>
-          <p:cNvPr id="2" name="Title 1"/>
-          <p:cNvSpPr>
-            <a:spLocks noGrp="1"/>
-          </p:cNvSpPr>
-          <p:nvPr>
-            <p:ph type="title"/>
-          </p:nvPr>
-        </p:nvSpPr>
-        <p:spPr/>
-        <p:txBody>
-          <a:bodyPr/>
-          <a:lstStyle/>
-          <a:p>
-            <a:r>
-              <a:rPr dirty="0"/>
-              <a:t>How To Present Insights To Non-Technical Audience</a:t>
-            </a:r>
-          </a:p>
-        </p:txBody>
-      </p:sp>
-      <p:sp>
-        <p:nvSpPr>
-          <p:cNvPr id="3" name="Content Placeholder 2"/>
-          <p:cNvSpPr>
-            <a:spLocks noGrp="1"/>
-          </p:cNvSpPr>
-          <p:nvPr>
-            <p:ph idx="1"/>
-          </p:nvPr>
-        </p:nvSpPr>
-        <p:spPr/>
-        <p:txBody>
-          <a:bodyPr/>
-          <a:lstStyle/>
-          <a:p>
-            <a:pPr>
-              <a:defRPr sz="2200"/>
-            </a:pPr>
-            <a:r>
-              <a:t>Start with business problem, not algorithm name.</a:t>
-            </a:r>
-          </a:p>
-          <a:p>
-            <a:pPr>
-              <a:defRPr sz="2200"/>
-            </a:pPr>
-            <a:r>
-              <a:t>Use before and after story: what action this model enables.</a:t>
-            </a:r>
-          </a:p>
-          <a:p>
-            <a:pPr>
-              <a:defRPr sz="2200"/>
-            </a:pPr>
-            <a:r>
-              <a:t>Show one chart, one risk score, one recommended action.</a:t>
-            </a:r>
-          </a:p>
-          <a:p>
-            <a:pPr>
-              <a:defRPr sz="2200"/>
-            </a:pPr>
-            <a:r>
-              <a:t>End with measurable impact target (for example 20 percent cancellation reduction).</a:t>
-            </a:r>
-          </a:p>
-        </p:txBody>
-      </p:sp>
-    </p:spTree>
-  </p:cSld>
-  <p:clrMapOvr>
-    <a:masterClrMapping/>
-  </p:clrMapOvr>
-</p:sld>
-</file>
-
-<file path=ppt/slides/slide28.xml><?xml version="1.0" encoding="utf-8"?>
-<p:sld xmlns:a="http://schemas.openxmlformats.org/drawingml/2006/main" xmlns:r="http://schemas.openxmlformats.org/officeDocument/2006/relationships" xmlns:p="http://schemas.openxmlformats.org/presentationml/2006/main">
-  <p:cSld>
-    <p:spTree>
-      <p:nvGrpSpPr>
-        <p:cNvPr id="1" name=""/>
-        <p:cNvGrpSpPr/>
-        <p:nvPr/>
-      </p:nvGrpSpPr>
-      <p:grpSpPr>
-        <a:xfrm>
-          <a:off x="0" y="0"/>
-          <a:ext cx="0" cy="0"/>
-          <a:chOff x="0" y="0"/>
-          <a:chExt cx="0" cy="0"/>
-        </a:xfrm>
-      </p:grpSpPr>
-      <p:sp>
-        <p:nvSpPr>
-          <p:cNvPr id="2" name="Title 1"/>
-          <p:cNvSpPr>
-            <a:spLocks noGrp="1"/>
-          </p:cNvSpPr>
-          <p:nvPr>
-            <p:ph type="title"/>
-          </p:nvPr>
-        </p:nvSpPr>
-        <p:spPr/>
-        <p:txBody>
-          <a:bodyPr/>
-          <a:lstStyle/>
-          <a:p>
-            <a:r>
-              <a:rPr dirty="0"/>
-              <a:t>Operational Interventions Examples</a:t>
-            </a:r>
-          </a:p>
-        </p:txBody>
-      </p:sp>
-      <p:sp>
-        <p:nvSpPr>
-          <p:cNvPr id="3" name="Content Placeholder 2"/>
-          <p:cNvSpPr>
-            <a:spLocks noGrp="1"/>
-          </p:cNvSpPr>
-          <p:nvPr>
-            <p:ph idx="1"/>
-          </p:nvPr>
-        </p:nvSpPr>
-        <p:spPr/>
-        <p:txBody>
-          <a:bodyPr/>
-          <a:lstStyle/>
-          <a:p>
-            <a:pPr>
-              <a:defRPr sz="2200"/>
-            </a:pPr>
-            <a:r>
               <a:rPr dirty="0"/>
               <a:t>High customer cancellation risk: send ETA transparency or incentive.</a:t>
             </a:r>
@@ -5041,83 +4676,6 @@
             <a:r>
               <a:rPr dirty="0"/>
               <a:t>Low reliability route pair: monitor and improve matching strategy.</a:t>
-            </a:r>
-          </a:p>
-        </p:txBody>
-      </p:sp>
-    </p:spTree>
-  </p:cSld>
-  <p:clrMapOvr>
-    <a:masterClrMapping/>
-  </p:clrMapOvr>
-</p:sld>
-</file>
-
-<file path=ppt/slides/slide29.xml><?xml version="1.0" encoding="utf-8"?>
-<p:sld xmlns:a="http://schemas.openxmlformats.org/drawingml/2006/main" xmlns:r="http://schemas.openxmlformats.org/officeDocument/2006/relationships" xmlns:p="http://schemas.openxmlformats.org/presentationml/2006/main">
-  <p:cSld>
-    <p:spTree>
-      <p:nvGrpSpPr>
-        <p:cNvPr id="1" name=""/>
-        <p:cNvGrpSpPr/>
-        <p:nvPr/>
-      </p:nvGrpSpPr>
-      <p:grpSpPr>
-        <a:xfrm>
-          <a:off x="0" y="0"/>
-          <a:ext cx="0" cy="0"/>
-          <a:chOff x="0" y="0"/>
-          <a:chExt cx="0" cy="0"/>
-        </a:xfrm>
-      </p:grpSpPr>
-      <p:sp>
-        <p:nvSpPr>
-          <p:cNvPr id="2" name="Title 1"/>
-          <p:cNvSpPr>
-            <a:spLocks noGrp="1"/>
-          </p:cNvSpPr>
-          <p:nvPr>
-            <p:ph type="title"/>
-          </p:nvPr>
-        </p:nvSpPr>
-        <p:spPr/>
-        <p:txBody>
-          <a:bodyPr/>
-          <a:lstStyle/>
-          <a:p>
-            <a:r>
-              <a:t>Part 7</a:t>
-            </a:r>
-          </a:p>
-        </p:txBody>
-      </p:sp>
-      <p:sp>
-        <p:nvSpPr>
-          <p:cNvPr id="3" name="TextBox 2"/>
-          <p:cNvSpPr txBox="1"/>
-          <p:nvPr/>
-        </p:nvSpPr>
-        <p:spPr>
-          <a:xfrm>
-            <a:off x="914400" y="2011680"/>
-            <a:ext cx="10058400" cy="2286000"/>
-          </a:xfrm>
-          <a:prstGeom prst="rect">
-            <a:avLst/>
-          </a:prstGeom>
-          <a:noFill/>
-        </p:spPr>
-        <p:txBody>
-          <a:bodyPr wrap="none">
-            <a:spAutoFit/>
-          </a:bodyPr>
-          <a:lstStyle/>
-          <a:p>
-            <a:pPr>
-              <a:defRPr sz="2800"/>
-            </a:pPr>
-            <a:r>
-              <a:t>Project submission and student evaluation readiness</a:t>
             </a:r>
           </a:p>
         </p:txBody>
@@ -5163,84 +4721,12 @@
           <a:lstStyle/>
           <a:p>
             <a:r>
-              <a:t>Part 1</a:t>
-            </a:r>
-          </a:p>
-        </p:txBody>
-      </p:sp>
-      <p:sp>
-        <p:nvSpPr>
-          <p:cNvPr id="3" name="TextBox 2"/>
-          <p:cNvSpPr txBox="1"/>
-          <p:nvPr/>
-        </p:nvSpPr>
-        <p:spPr>
-          <a:xfrm>
-            <a:off x="914400" y="2011680"/>
-            <a:ext cx="10058400" cy="2286000"/>
-          </a:xfrm>
-          <a:prstGeom prst="rect">
-            <a:avLst/>
-          </a:prstGeom>
-          <a:noFill/>
-        </p:spPr>
-        <p:txBody>
-          <a:bodyPr wrap="none">
-            <a:spAutoFit/>
-          </a:bodyPr>
-          <a:lstStyle/>
-          <a:p>
-            <a:pPr>
-              <a:defRPr sz="2800"/>
-            </a:pPr>
-            <a:r>
-              <a:t>Understand the problem in simple business language</a:t>
-            </a:r>
-          </a:p>
-        </p:txBody>
-      </p:sp>
-    </p:spTree>
-  </p:cSld>
-  <p:clrMapOvr>
-    <a:masterClrMapping/>
-  </p:clrMapOvr>
-</p:sld>
-</file>
-
-<file path=ppt/slides/slide30.xml><?xml version="1.0" encoding="utf-8"?>
-<p:sld xmlns:a="http://schemas.openxmlformats.org/drawingml/2006/main" xmlns:r="http://schemas.openxmlformats.org/officeDocument/2006/relationships" xmlns:p="http://schemas.openxmlformats.org/presentationml/2006/main">
-  <p:cSld>
-    <p:spTree>
-      <p:nvGrpSpPr>
-        <p:cNvPr id="1" name=""/>
-        <p:cNvGrpSpPr/>
-        <p:nvPr/>
-      </p:nvGrpSpPr>
-      <p:grpSpPr>
-        <a:xfrm>
-          <a:off x="0" y="0"/>
-          <a:ext cx="0" cy="0"/>
-          <a:chOff x="0" y="0"/>
-          <a:chExt cx="0" cy="0"/>
-        </a:xfrm>
-      </p:grpSpPr>
-      <p:sp>
-        <p:nvSpPr>
-          <p:cNvPr id="2" name="Title 1"/>
-          <p:cNvSpPr>
-            <a:spLocks noGrp="1"/>
-          </p:cNvSpPr>
-          <p:nvPr>
-            <p:ph type="title"/>
-          </p:nvPr>
-        </p:nvSpPr>
-        <p:spPr/>
-        <p:txBody>
-          <a:bodyPr/>
-          <a:lstStyle/>
-          <a:p>
-            <a:r>
-              <a:t>Final Submission Checklist</a:t>
+              <a:rPr lang="en-US" dirty="0"/>
+              <a:t>Problems </a:t>
+            </a:r>
+            <a:r>
+              <a:rPr dirty="0"/>
+              <a:t>We Are Solving</a:t>
             </a:r>
           </a:p>
         </p:txBody>
@@ -5264,305 +4750,35 @@
               <a:defRPr sz="2200"/>
             </a:pPr>
             <a:r>
-              <a:t>Code runs end to end without manual edits.</a:t>
-            </a:r>
-          </a:p>
-          <a:p>
-            <a:pPr>
-              <a:defRPr sz="2200"/>
-            </a:pPr>
-            <a:r>
-              <a:t>README explains setup and run commands clearly.</a:t>
-            </a:r>
-          </a:p>
-          <a:p>
-            <a:pPr>
-              <a:defRPr sz="2200"/>
-            </a:pPr>
-            <a:r>
-              <a:t>Metrics and charts are included in final report.</a:t>
-            </a:r>
-          </a:p>
-          <a:p>
-            <a:pPr>
-              <a:defRPr sz="2200"/>
-            </a:pPr>
-            <a:r>
-              <a:t>Students can explain one business decision per model.</a:t>
-            </a:r>
-          </a:p>
-        </p:txBody>
-      </p:sp>
-    </p:spTree>
-  </p:cSld>
-  <p:clrMapOvr>
-    <a:masterClrMapping/>
-  </p:clrMapOvr>
-</p:sld>
-</file>
-
-<file path=ppt/slides/slide31.xml><?xml version="1.0" encoding="utf-8"?>
-<p:sld xmlns:a="http://schemas.openxmlformats.org/drawingml/2006/main" xmlns:r="http://schemas.openxmlformats.org/officeDocument/2006/relationships" xmlns:p="http://schemas.openxmlformats.org/presentationml/2006/main">
-  <p:cSld>
-    <p:spTree>
-      <p:nvGrpSpPr>
-        <p:cNvPr id="1" name=""/>
-        <p:cNvGrpSpPr/>
-        <p:nvPr/>
-      </p:nvGrpSpPr>
-      <p:grpSpPr>
-        <a:xfrm>
-          <a:off x="0" y="0"/>
-          <a:ext cx="0" cy="0"/>
-          <a:chOff x="0" y="0"/>
-          <a:chExt cx="0" cy="0"/>
-        </a:xfrm>
-      </p:grpSpPr>
-      <p:sp>
-        <p:nvSpPr>
-          <p:cNvPr id="2" name="Title 1"/>
-          <p:cNvSpPr>
-            <a:spLocks noGrp="1"/>
-          </p:cNvSpPr>
-          <p:nvPr>
-            <p:ph type="title"/>
-          </p:nvPr>
-        </p:nvSpPr>
-        <p:spPr/>
-        <p:txBody>
-          <a:bodyPr/>
-          <a:lstStyle/>
-          <a:p>
-            <a:r>
-              <a:t>Common Student Errors And Fixes</a:t>
-            </a:r>
-          </a:p>
-        </p:txBody>
-      </p:sp>
-      <p:sp>
-        <p:nvSpPr>
-          <p:cNvPr id="3" name="Content Placeholder 2"/>
-          <p:cNvSpPr>
-            <a:spLocks noGrp="1"/>
-          </p:cNvSpPr>
-          <p:nvPr>
-            <p:ph idx="1"/>
-          </p:nvPr>
-        </p:nvSpPr>
-        <p:spPr/>
-        <p:txBody>
-          <a:bodyPr/>
-          <a:lstStyle/>
-          <a:p>
-            <a:pPr>
-              <a:defRPr sz="2200"/>
-            </a:pPr>
-            <a:r>
-              <a:t>Error: module not found. Fix: install requirements in active environment.</a:t>
-            </a:r>
-          </a:p>
-          <a:p>
-            <a:pPr>
-              <a:defRPr sz="2200"/>
-            </a:pPr>
-            <a:r>
-              <a:t>Error: file path issue. Fix: run commands from project root folder.</a:t>
-            </a:r>
-          </a:p>
-          <a:p>
-            <a:pPr>
-              <a:defRPr sz="2200"/>
-            </a:pPr>
-            <a:r>
-              <a:t>Error: unrealistic perfect scores. Fix: review leakage-prone features.</a:t>
-            </a:r>
-          </a:p>
-          <a:p>
-            <a:pPr>
-              <a:defRPr sz="2200"/>
-            </a:pPr>
-            <a:r>
-              <a:t>Error: presentation confusion. Fix: explain use case first, metric later.</a:t>
-            </a:r>
-          </a:p>
-        </p:txBody>
-      </p:sp>
-    </p:spTree>
-  </p:cSld>
-  <p:clrMapOvr>
-    <a:masterClrMapping/>
-  </p:clrMapOvr>
-</p:sld>
-</file>
-
-<file path=ppt/slides/slide32.xml><?xml version="1.0" encoding="utf-8"?>
-<p:sld xmlns:a="http://schemas.openxmlformats.org/drawingml/2006/main" xmlns:r="http://schemas.openxmlformats.org/officeDocument/2006/relationships" xmlns:p="http://schemas.openxmlformats.org/presentationml/2006/main">
-  <p:cSld>
-    <p:spTree>
-      <p:nvGrpSpPr>
-        <p:cNvPr id="1" name=""/>
-        <p:cNvGrpSpPr/>
-        <p:nvPr/>
-      </p:nvGrpSpPr>
-      <p:grpSpPr>
-        <a:xfrm>
-          <a:off x="0" y="0"/>
-          <a:ext cx="0" cy="0"/>
-          <a:chOff x="0" y="0"/>
-          <a:chExt cx="0" cy="0"/>
-        </a:xfrm>
-      </p:grpSpPr>
-      <p:sp>
-        <p:nvSpPr>
-          <p:cNvPr id="2" name="Title 1"/>
-          <p:cNvSpPr>
-            <a:spLocks noGrp="1"/>
-          </p:cNvSpPr>
-          <p:nvPr>
-            <p:ph type="title"/>
-          </p:nvPr>
-        </p:nvSpPr>
-        <p:spPr/>
-        <p:txBody>
-          <a:bodyPr/>
-          <a:lstStyle/>
-          <a:p>
-            <a:r>
-              <a:t>Suggested 2-Hour Teaching Plan</a:t>
-            </a:r>
-          </a:p>
-        </p:txBody>
-      </p:sp>
-      <p:sp>
-        <p:nvSpPr>
-          <p:cNvPr id="3" name="Content Placeholder 2"/>
-          <p:cNvSpPr>
-            <a:spLocks noGrp="1"/>
-          </p:cNvSpPr>
-          <p:nvPr>
-            <p:ph idx="1"/>
-          </p:nvPr>
-        </p:nvSpPr>
-        <p:spPr/>
-        <p:txBody>
-          <a:bodyPr/>
-          <a:lstStyle/>
-          <a:p>
-            <a:pPr>
-              <a:defRPr sz="2200"/>
-            </a:pPr>
-            <a:r>
-              <a:t>0-20 min: Business context and use cases</a:t>
-            </a:r>
-          </a:p>
-          <a:p>
-            <a:pPr>
-              <a:defRPr sz="2200"/>
-            </a:pPr>
-            <a:r>
-              <a:t>20-50 min: Data files and preprocessing walkthrough</a:t>
-            </a:r>
-          </a:p>
-          <a:p>
-            <a:pPr>
-              <a:defRPr sz="2200"/>
-            </a:pPr>
-            <a:r>
-              <a:t>50-90 min: Training pipeline and metric interpretation</a:t>
-            </a:r>
-          </a:p>
-          <a:p>
-            <a:pPr>
-              <a:defRPr sz="2200"/>
-            </a:pPr>
-            <a:r>
-              <a:t>90-120 min: Streamlit demo and Q and A</a:t>
-            </a:r>
-          </a:p>
-        </p:txBody>
-      </p:sp>
-    </p:spTree>
-  </p:cSld>
-  <p:clrMapOvr>
-    <a:masterClrMapping/>
-  </p:clrMapOvr>
-</p:sld>
-</file>
-
-<file path=ppt/slides/slide33.xml><?xml version="1.0" encoding="utf-8"?>
-<p:sld xmlns:a="http://schemas.openxmlformats.org/drawingml/2006/main" xmlns:r="http://schemas.openxmlformats.org/officeDocument/2006/relationships" xmlns:p="http://schemas.openxmlformats.org/presentationml/2006/main">
-  <p:cSld>
-    <p:spTree>
-      <p:nvGrpSpPr>
-        <p:cNvPr id="1" name=""/>
-        <p:cNvGrpSpPr/>
-        <p:nvPr/>
-      </p:nvGrpSpPr>
-      <p:grpSpPr>
-        <a:xfrm>
-          <a:off x="0" y="0"/>
-          <a:ext cx="0" cy="0"/>
-          <a:chOff x="0" y="0"/>
-          <a:chExt cx="0" cy="0"/>
-        </a:xfrm>
-      </p:grpSpPr>
-      <p:sp>
-        <p:nvSpPr>
-          <p:cNvPr id="2" name="Title 1"/>
-          <p:cNvSpPr>
-            <a:spLocks noGrp="1"/>
-          </p:cNvSpPr>
-          <p:nvPr>
-            <p:ph type="title"/>
-          </p:nvPr>
-        </p:nvSpPr>
-        <p:spPr/>
-        <p:txBody>
-          <a:bodyPr/>
-          <a:lstStyle/>
-          <a:p>
-            <a:r>
-              <a:t>Thank You Slide</a:t>
-            </a:r>
-          </a:p>
-        </p:txBody>
-      </p:sp>
-      <p:sp>
-        <p:nvSpPr>
-          <p:cNvPr id="3" name="Content Placeholder 2"/>
-          <p:cNvSpPr>
-            <a:spLocks noGrp="1"/>
-          </p:cNvSpPr>
-          <p:nvPr>
-            <p:ph idx="1"/>
-          </p:nvPr>
-        </p:nvSpPr>
-        <p:spPr/>
-        <p:txBody>
-          <a:bodyPr/>
-          <a:lstStyle/>
-          <a:p>
-            <a:pPr>
-              <a:defRPr sz="2200"/>
-            </a:pPr>
-            <a:r>
-              <a:t>Students should now be able to run, explain, and present the project.</a:t>
-            </a:r>
-          </a:p>
-          <a:p>
-            <a:pPr>
-              <a:defRPr sz="2200"/>
-            </a:pPr>
-            <a:r>
-              <a:t>Next class task: remove leakage and compare realistic model metrics.</a:t>
-            </a:r>
-          </a:p>
-          <a:p>
-            <a:pPr>
-              <a:defRPr sz="2200"/>
-            </a:pPr>
-            <a:r>
-              <a:t>Optional extension: build FastAPI endpoint for live prediction.</a:t>
+              <a:rPr dirty="0"/>
+              <a:t>Will this booking be completed, cancelled, or incomplete?</a:t>
+            </a:r>
+          </a:p>
+          <a:p>
+            <a:pPr>
+              <a:defRPr sz="2200"/>
+            </a:pPr>
+            <a:r>
+              <a:rPr dirty="0"/>
+              <a:t>What fare should we expect before ride starts?</a:t>
+            </a:r>
+          </a:p>
+          <a:p>
+            <a:pPr>
+              <a:defRPr sz="2200"/>
+            </a:pPr>
+            <a:r>
+              <a:rPr dirty="0"/>
+              <a:t>Is this customer likely to cancel?</a:t>
+            </a:r>
+          </a:p>
+          <a:p>
+            <a:pPr>
+              <a:defRPr sz="2200"/>
+            </a:pPr>
+            <a:r>
+              <a:rPr dirty="0"/>
+              <a:t>Is this driver likely to cause delay or incomplete trip?</a:t>
             </a:r>
           </a:p>
         </p:txBody>
@@ -5608,8 +4824,7 @@
           <a:lstStyle/>
           <a:p>
             <a:r>
-              <a:rPr dirty="0"/>
-              <a:t>Project Story</a:t>
+              <a:t>4 ML Models In This Project</a:t>
             </a:r>
           </a:p>
         </p:txBody>
@@ -5633,35 +4848,31 @@
               <a:defRPr sz="2200"/>
             </a:pPr>
             <a:r>
-              <a:rPr dirty="0"/>
-              <a:t>Rapido gets many bookings every day.</a:t>
-            </a:r>
-          </a:p>
-          <a:p>
-            <a:pPr>
-              <a:defRPr sz="2200"/>
-            </a:pPr>
-            <a:r>
-              <a:rPr dirty="0"/>
-              <a:t>Some rides get cancelled, some are delayed, and fares are hard to predict.</a:t>
-            </a:r>
-          </a:p>
-          <a:p>
-            <a:pPr>
-              <a:defRPr sz="2200"/>
-            </a:pPr>
-            <a:r>
-              <a:rPr dirty="0"/>
-              <a:t>If we predict these early, operations can take action before problems happen.</a:t>
-            </a:r>
-          </a:p>
-          <a:p>
-            <a:pPr>
-              <a:defRPr sz="2200"/>
-            </a:pPr>
-            <a:r>
-              <a:rPr dirty="0"/>
-              <a:t>Machine learning helps us convert past trip data into predictions.</a:t>
+              <a:t>Model 1: Ride outcome prediction (multi-class classification)</a:t>
+            </a:r>
+          </a:p>
+          <a:p>
+            <a:pPr>
+              <a:defRPr sz="2200"/>
+            </a:pPr>
+            <a:r>
+              <a:t>Model 2: Fare prediction (regression)</a:t>
+            </a:r>
+          </a:p>
+          <a:p>
+            <a:pPr>
+              <a:defRPr sz="2200"/>
+            </a:pPr>
+            <a:r>
+              <a:t>Model 3: Customer cancellation risk (binary classification)</a:t>
+            </a:r>
+          </a:p>
+          <a:p>
+            <a:pPr>
+              <a:defRPr sz="2200"/>
+            </a:pPr>
+            <a:r>
+              <a:t>Model 4: Driver delay risk (binary classification)</a:t>
             </a:r>
           </a:p>
         </p:txBody>
@@ -5707,55 +4918,38 @@
           <a:lstStyle/>
           <a:p>
             <a:r>
-              <a:t>Business Questions We Are Solving</a:t>
-            </a:r>
-          </a:p>
-        </p:txBody>
-      </p:sp>
-      <p:sp>
-        <p:nvSpPr>
-          <p:cNvPr id="3" name="Content Placeholder 2"/>
-          <p:cNvSpPr>
-            <a:spLocks noGrp="1"/>
-          </p:cNvSpPr>
-          <p:nvPr>
-            <p:ph idx="1"/>
-          </p:nvPr>
-        </p:nvSpPr>
-        <p:spPr/>
-        <p:txBody>
-          <a:bodyPr/>
-          <a:lstStyle/>
-          <a:p>
-            <a:pPr>
-              <a:defRPr sz="2200"/>
-            </a:pPr>
-            <a:r>
-              <a:t>Will this booking be completed, cancelled, or incomplete?</a:t>
-            </a:r>
-          </a:p>
-          <a:p>
-            <a:pPr>
-              <a:defRPr sz="2200"/>
-            </a:pPr>
-            <a:r>
-              <a:t>What fare should we expect before ride starts?</a:t>
-            </a:r>
-          </a:p>
-          <a:p>
-            <a:pPr>
-              <a:defRPr sz="2200"/>
-            </a:pPr>
-            <a:r>
-              <a:t>Is this customer likely to cancel?</a:t>
-            </a:r>
-          </a:p>
-          <a:p>
-            <a:pPr>
-              <a:defRPr sz="2200"/>
-            </a:pPr>
-            <a:r>
-              <a:t>Is this driver likely to cause delay or incomplete trip?</a:t>
+              <a:t>Part 2</a:t>
+            </a:r>
+          </a:p>
+        </p:txBody>
+      </p:sp>
+      <p:sp>
+        <p:nvSpPr>
+          <p:cNvPr id="3" name="TextBox 2"/>
+          <p:cNvSpPr txBox="1"/>
+          <p:nvPr/>
+        </p:nvSpPr>
+        <p:spPr>
+          <a:xfrm>
+            <a:off x="914400" y="2011680"/>
+            <a:ext cx="10058400" cy="2286000"/>
+          </a:xfrm>
+          <a:prstGeom prst="rect">
+            <a:avLst/>
+          </a:prstGeom>
+          <a:noFill/>
+        </p:spPr>
+        <p:txBody>
+          <a:bodyPr wrap="none">
+            <a:spAutoFit/>
+          </a:bodyPr>
+          <a:lstStyle/>
+          <a:p>
+            <a:pPr>
+              <a:defRPr sz="2800"/>
+            </a:pPr>
+            <a:r>
+              <a:t>Know your data before touching machine learning</a:t>
             </a:r>
           </a:p>
         </p:txBody>
@@ -5801,7 +4995,8 @@
           <a:lstStyle/>
           <a:p>
             <a:r>
-              <a:t>4 ML Models In This Project</a:t>
+              <a:rPr dirty="0"/>
+              <a:t>Dataset Files And Purpose</a:t>
             </a:r>
           </a:p>
         </p:txBody>
@@ -5825,31 +5020,39 @@
               <a:defRPr sz="2200"/>
             </a:pPr>
             <a:r>
-              <a:t>Model 1: Ride outcome prediction (multi-class classification)</a:t>
-            </a:r>
-          </a:p>
-          <a:p>
-            <a:pPr>
-              <a:defRPr sz="2200"/>
-            </a:pPr>
-            <a:r>
-              <a:t>Model 2: Fare prediction (regression)</a:t>
-            </a:r>
-          </a:p>
-          <a:p>
-            <a:pPr>
-              <a:defRPr sz="2200"/>
-            </a:pPr>
-            <a:r>
-              <a:t>Model 3: Customer cancellation risk (binary classification)</a:t>
-            </a:r>
-          </a:p>
-          <a:p>
-            <a:pPr>
-              <a:defRPr sz="2200"/>
-            </a:pPr>
-            <a:r>
-              <a:t>Model 4: Driver delay risk (binary classification)</a:t>
+              <a:t>bookings: core ride transactions and booking status</a:t>
+            </a:r>
+          </a:p>
+          <a:p>
+            <a:pPr>
+              <a:defRPr sz="2200"/>
+            </a:pPr>
+            <a:r>
+              <a:t>customers: customer profile and cancellation behavior</a:t>
+            </a:r>
+          </a:p>
+          <a:p>
+            <a:pPr>
+              <a:defRPr sz="2200"/>
+            </a:pPr>
+            <a:r>
+              <a:t>drivers: driver performance and delay history</a:t>
+            </a:r>
+          </a:p>
+          <a:p>
+            <a:pPr>
+              <a:defRPr sz="2200"/>
+            </a:pPr>
+            <a:r>
+              <a:t>location_demand: demand patterns by place and hour</a:t>
+            </a:r>
+          </a:p>
+          <a:p>
+            <a:pPr>
+              <a:defRPr sz="2200"/>
+            </a:pPr>
+            <a:r>
+              <a:t>time_features: day, weekend, season and peak indicators</a:t>
             </a:r>
           </a:p>
         </p:txBody>
@@ -5895,38 +5098,100 @@
           <a:lstStyle/>
           <a:p>
             <a:r>
-              <a:t>Part 2</a:t>
-            </a:r>
-          </a:p>
-        </p:txBody>
-      </p:sp>
-      <p:sp>
-        <p:nvSpPr>
-          <p:cNvPr id="3" name="TextBox 2"/>
-          <p:cNvSpPr txBox="1"/>
-          <p:nvPr/>
-        </p:nvSpPr>
-        <p:spPr>
-          <a:xfrm>
-            <a:off x="914400" y="2011680"/>
-            <a:ext cx="10058400" cy="2286000"/>
-          </a:xfrm>
-          <a:prstGeom prst="rect">
-            <a:avLst/>
-          </a:prstGeom>
-          <a:noFill/>
-        </p:spPr>
-        <p:txBody>
-          <a:bodyPr wrap="none">
-            <a:spAutoFit/>
-          </a:bodyPr>
-          <a:lstStyle/>
-          <a:p>
-            <a:pPr>
-              <a:defRPr sz="2800"/>
-            </a:pPr>
-            <a:r>
-              <a:t>Know your data before touching machine learning</a:t>
+              <a:rPr dirty="0"/>
+              <a:t>Important Columns</a:t>
+            </a:r>
+          </a:p>
+        </p:txBody>
+      </p:sp>
+      <p:sp>
+        <p:nvSpPr>
+          <p:cNvPr id="3" name="Content Placeholder 2"/>
+          <p:cNvSpPr>
+            <a:spLocks noGrp="1"/>
+          </p:cNvSpPr>
+          <p:nvPr>
+            <p:ph idx="1"/>
+          </p:nvPr>
+        </p:nvSpPr>
+        <p:spPr/>
+        <p:txBody>
+          <a:bodyPr/>
+          <a:lstStyle/>
+          <a:p>
+            <a:pPr>
+              <a:defRPr sz="2200"/>
+            </a:pPr>
+            <a:r>
+              <a:rPr dirty="0" err="1"/>
+              <a:t>booking_status</a:t>
+            </a:r>
+            <a:r>
+              <a:rPr dirty="0"/>
+              <a:t> is the main ride outcome label.</a:t>
+            </a:r>
+          </a:p>
+          <a:p>
+            <a:pPr>
+              <a:defRPr sz="2200"/>
+            </a:pPr>
+            <a:r>
+              <a:rPr dirty="0" err="1"/>
+              <a:t>booking_value</a:t>
+            </a:r>
+            <a:r>
+              <a:rPr dirty="0"/>
+              <a:t> is the fare amount we predict in regression.</a:t>
+            </a:r>
+          </a:p>
+          <a:p>
+            <a:pPr>
+              <a:defRPr sz="2200"/>
+            </a:pPr>
+            <a:r>
+              <a:rPr dirty="0" err="1"/>
+              <a:t>hour_of_day</a:t>
+            </a:r>
+            <a:r>
+              <a:rPr dirty="0"/>
+              <a:t>, </a:t>
+            </a:r>
+            <a:r>
+              <a:rPr dirty="0" err="1"/>
+              <a:t>traffic_level</a:t>
+            </a:r>
+            <a:r>
+              <a:rPr dirty="0"/>
+              <a:t>, </a:t>
+            </a:r>
+            <a:r>
+              <a:rPr dirty="0" err="1"/>
+              <a:t>weather_condition</a:t>
+            </a:r>
+            <a:r>
+              <a:rPr dirty="0"/>
+              <a:t> influence demand and cancellation.</a:t>
+            </a:r>
+          </a:p>
+          <a:p>
+            <a:pPr>
+              <a:defRPr sz="2200"/>
+            </a:pPr>
+            <a:r>
+              <a:rPr dirty="0" err="1"/>
+              <a:t>customer_cancel_flag</a:t>
+            </a:r>
+            <a:r>
+              <a:rPr dirty="0"/>
+              <a:t> and </a:t>
+            </a:r>
+            <a:r>
+              <a:rPr dirty="0" err="1"/>
+              <a:t>driver_delay_flag</a:t>
+            </a:r>
+            <a:r>
+              <a:rPr dirty="0"/>
+              <a:t> are risk labels.</a:t>
             </a:r>
           </a:p>
         </p:txBody>
@@ -5972,63 +5237,38 @@
           <a:lstStyle/>
           <a:p>
             <a:r>
-              <a:t>Dataset Files And Purpose</a:t>
-            </a:r>
-          </a:p>
-        </p:txBody>
-      </p:sp>
-      <p:sp>
-        <p:nvSpPr>
-          <p:cNvPr id="3" name="Content Placeholder 2"/>
-          <p:cNvSpPr>
-            <a:spLocks noGrp="1"/>
-          </p:cNvSpPr>
-          <p:nvPr>
-            <p:ph idx="1"/>
-          </p:nvPr>
-        </p:nvSpPr>
-        <p:spPr/>
-        <p:txBody>
-          <a:bodyPr/>
-          <a:lstStyle/>
-          <a:p>
-            <a:pPr>
-              <a:defRPr sz="2200"/>
-            </a:pPr>
-            <a:r>
-              <a:t>bookings: core ride transactions and booking status</a:t>
-            </a:r>
-          </a:p>
-          <a:p>
-            <a:pPr>
-              <a:defRPr sz="2200"/>
-            </a:pPr>
-            <a:r>
-              <a:t>customers: customer profile and cancellation behavior</a:t>
-            </a:r>
-          </a:p>
-          <a:p>
-            <a:pPr>
-              <a:defRPr sz="2200"/>
-            </a:pPr>
-            <a:r>
-              <a:t>drivers: driver performance and delay history</a:t>
-            </a:r>
-          </a:p>
-          <a:p>
-            <a:pPr>
-              <a:defRPr sz="2200"/>
-            </a:pPr>
-            <a:r>
-              <a:t>location_demand: demand patterns by place and hour</a:t>
-            </a:r>
-          </a:p>
-          <a:p>
-            <a:pPr>
-              <a:defRPr sz="2200"/>
-            </a:pPr>
-            <a:r>
-              <a:t>time_features: day, weekend, season and peak indicators</a:t>
+              <a:t>Part 3</a:t>
+            </a:r>
+          </a:p>
+        </p:txBody>
+      </p:sp>
+      <p:sp>
+        <p:nvSpPr>
+          <p:cNvPr id="3" name="TextBox 2"/>
+          <p:cNvSpPr txBox="1"/>
+          <p:nvPr/>
+        </p:nvSpPr>
+        <p:spPr>
+          <a:xfrm>
+            <a:off x="914400" y="2011680"/>
+            <a:ext cx="10058400" cy="2286000"/>
+          </a:xfrm>
+          <a:prstGeom prst="rect">
+            <a:avLst/>
+          </a:prstGeom>
+          <a:noFill/>
+        </p:spPr>
+        <p:txBody>
+          <a:bodyPr wrap="none">
+            <a:spAutoFit/>
+          </a:bodyPr>
+          <a:lstStyle/>
+          <a:p>
+            <a:pPr>
+              <a:defRPr sz="2800"/>
+            </a:pPr>
+            <a:r>
+              <a:t>Environment setup and project execution</a:t>
             </a:r>
           </a:p>
         </p:txBody>
@@ -6070,14 +5310,11 @@
         </p:nvSpPr>
         <p:spPr/>
         <p:txBody>
-          <a:bodyPr>
-            <a:normAutofit/>
-          </a:bodyPr>
-          <a:lstStyle/>
-          <a:p>
-            <a:r>
-              <a:rPr dirty="0"/>
-              <a:t>Important Columns</a:t>
+          <a:bodyPr/>
+          <a:lstStyle/>
+          <a:p>
+            <a:r>
+              <a:t>Step 1: Open The Project</a:t>
             </a:r>
           </a:p>
         </p:txBody>
@@ -6101,76 +5338,24 @@
               <a:defRPr sz="2200"/>
             </a:pPr>
             <a:r>
-              <a:rPr dirty="0" err="1"/>
-              <a:t>booking_status</a:t>
-            </a:r>
-            <a:r>
-              <a:rPr dirty="0"/>
-              <a:t> is the main ride outcome label.</a:t>
-            </a:r>
-          </a:p>
-          <a:p>
-            <a:pPr>
-              <a:defRPr sz="2200"/>
-            </a:pPr>
-            <a:r>
-              <a:rPr dirty="0" err="1"/>
-              <a:t>booking_value</a:t>
-            </a:r>
-            <a:r>
-              <a:rPr dirty="0"/>
-              <a:t> is the fare amount we predict in regression.</a:t>
-            </a:r>
-          </a:p>
-          <a:p>
-            <a:pPr>
-              <a:defRPr sz="2200"/>
-            </a:pPr>
-            <a:r>
-              <a:rPr dirty="0" err="1"/>
-              <a:t>hour_of_day</a:t>
-            </a:r>
-            <a:r>
-              <a:rPr dirty="0"/>
-              <a:t>, </a:t>
-            </a:r>
-            <a:r>
-              <a:rPr dirty="0" err="1"/>
-              <a:t>traffic_level</a:t>
-            </a:r>
-            <a:r>
-              <a:rPr dirty="0"/>
-              <a:t>, </a:t>
-            </a:r>
-            <a:r>
-              <a:rPr dirty="0" err="1"/>
-              <a:t>weather_condition</a:t>
-            </a:r>
-            <a:r>
-              <a:rPr dirty="0"/>
-              <a:t> influence demand and cancellation.</a:t>
-            </a:r>
-          </a:p>
-          <a:p>
-            <a:pPr>
-              <a:defRPr sz="2200"/>
-            </a:pPr>
-            <a:r>
-              <a:rPr dirty="0" err="1"/>
-              <a:t>customer_cancel_flag</a:t>
-            </a:r>
-            <a:r>
-              <a:rPr dirty="0"/>
-              <a:t> and </a:t>
-            </a:r>
-            <a:r>
-              <a:rPr dirty="0" err="1"/>
-              <a:t>driver_delay_flag</a:t>
-            </a:r>
-            <a:r>
-              <a:rPr dirty="0"/>
-              <a:t> are risk labels.</a:t>
-            </a:r>
+              <a:rPr dirty="0"/>
+              <a:t>Open VS Code.</a:t>
+            </a:r>
+          </a:p>
+          <a:p>
+            <a:pPr>
+              <a:defRPr sz="2200"/>
+            </a:pPr>
+            <a:r>
+              <a:rPr dirty="0"/>
+              <a:t>Open folder PROJECT.</a:t>
+            </a:r>
+          </a:p>
+          <a:p>
+            <a:pPr>
+              <a:defRPr sz="2200"/>
+            </a:pPr>
+            <a:endParaRPr dirty="0"/>
           </a:p>
         </p:txBody>
       </p:sp>

</xml_diff>